<commit_message>
docs: refine daily status presentation layout
Co-authored-by: 程序员鱼皮 <592789970@qq.com>
</commit_message>
<xml_diff>
--- a/docs/reports/project-status-2026-07-19.pptx
+++ b/docs/reports/project-status-2026-07-19.pptx
@@ -2003,7 +2003,7 @@
         <p:spPr>
           <a:xfrm>
             <a:off x="704088" y="3822192"/>
-            <a:ext cx="1627632" cy="310896"/>
+            <a:ext cx="1993392" cy="310896"/>
           </a:xfrm>
           <a:prstGeom prst="roundRect">
             <a:avLst>
@@ -2030,7 +2030,7 @@
         <p:spPr>
           <a:xfrm>
             <a:off x="704088" y="3858768"/>
-            <a:ext cx="1627632" cy="164592"/>
+            <a:ext cx="1993392" cy="164592"/>
           </a:xfrm>
           <a:prstGeom prst="rect">
             <a:avLst/>
@@ -2054,7 +2054,7 @@
                 <a:ea typeface="Calibri" pitchFamily="34" charset="-122"/>
                 <a:cs typeface="Calibri" pitchFamily="34" charset="-120"/>
               </a:rPr>
-              <a:t>项目维护者 / 团队</a:t>
+              <a:t>面向：项目维护者与团队</a:t>
             </a:r>
             <a:endParaRPr lang="en-US" sz="1000" dirty="0"/>
           </a:p>
@@ -2546,7 +2546,7 @@
         <p:spPr>
           <a:xfrm>
             <a:off x="1600200" y="1682496"/>
-            <a:ext cx="7452360" cy="795528"/>
+            <a:ext cx="7178040" cy="795528"/>
           </a:xfrm>
           <a:prstGeom prst="roundRect">
             <a:avLst>
@@ -2813,7 +2813,7 @@
         <p:spPr>
           <a:xfrm>
             <a:off x="1600200" y="2743200"/>
-            <a:ext cx="7452360" cy="795528"/>
+            <a:ext cx="7178040" cy="795528"/>
           </a:xfrm>
           <a:prstGeom prst="roundRect">
             <a:avLst>
@@ -3080,7 +3080,7 @@
         <p:spPr>
           <a:xfrm>
             <a:off x="1600200" y="3803904"/>
-            <a:ext cx="7452360" cy="795528"/>
+            <a:ext cx="7178040" cy="795528"/>
           </a:xfrm>
           <a:prstGeom prst="roundRect">
             <a:avLst>
@@ -3324,7 +3324,7 @@
         <p:spPr>
           <a:xfrm>
             <a:off x="1600200" y="4864608"/>
-            <a:ext cx="7452360" cy="795528"/>
+            <a:ext cx="7178040" cy="795528"/>
           </a:xfrm>
           <a:prstGeom prst="roundRect">
             <a:avLst>
@@ -3503,12 +3503,12 @@
         </p:nvSpPr>
         <p:spPr>
           <a:xfrm>
-            <a:off x="9464040" y="1682496"/>
-            <a:ext cx="2075688" cy="4261104"/>
+            <a:off x="9162288" y="1682496"/>
+            <a:ext cx="2377440" cy="4261104"/>
           </a:xfrm>
           <a:prstGeom prst="roundRect">
             <a:avLst>
-              <a:gd name="adj" fmla="val 3524"/>
+              <a:gd name="adj" fmla="val 3077"/>
             </a:avLst>
           </a:prstGeom>
           <a:solidFill>
@@ -3537,8 +3537,8 @@
         </p:nvSpPr>
         <p:spPr>
           <a:xfrm>
-            <a:off x="9784080" y="1993392"/>
-            <a:ext cx="1426464" cy="292608"/>
+            <a:off x="9528048" y="1993392"/>
+            <a:ext cx="1572768" cy="292608"/>
           </a:xfrm>
           <a:prstGeom prst="rect">
             <a:avLst/>
@@ -3576,7 +3576,7 @@
         </p:nvSpPr>
         <p:spPr>
           <a:xfrm>
-            <a:off x="9784080" y="2688336"/>
+            <a:off x="9528048" y="2688336"/>
             <a:ext cx="256032" cy="219456"/>
           </a:xfrm>
           <a:prstGeom prst="rect">
@@ -3615,8 +3615,8 @@
         </p:nvSpPr>
         <p:spPr>
           <a:xfrm>
-            <a:off x="10195560" y="2688336"/>
-            <a:ext cx="950976" cy="438912"/>
+            <a:off x="9939528" y="2688336"/>
+            <a:ext cx="1234440" cy="438912"/>
           </a:xfrm>
           <a:prstGeom prst="rect">
             <a:avLst/>
@@ -3656,7 +3656,7 @@
         </p:nvSpPr>
         <p:spPr>
           <a:xfrm>
-            <a:off x="9784080" y="3374136"/>
+            <a:off x="9528048" y="3374136"/>
             <a:ext cx="256032" cy="219456"/>
           </a:xfrm>
           <a:prstGeom prst="rect">
@@ -3695,8 +3695,8 @@
         </p:nvSpPr>
         <p:spPr>
           <a:xfrm>
-            <a:off x="10195560" y="3374136"/>
-            <a:ext cx="950976" cy="438912"/>
+            <a:off x="9939528" y="3374136"/>
+            <a:ext cx="1234440" cy="438912"/>
           </a:xfrm>
           <a:prstGeom prst="rect">
             <a:avLst/>
@@ -3722,7 +3722,7 @@
                 <a:ea typeface="Calibri" pitchFamily="34" charset="-122"/>
                 <a:cs typeface="Calibri" pitchFamily="34" charset="-120"/>
               </a:rPr>
-              <a:t>LangGraph 主链路接入范围？</a:t>
+              <a:t>LangGraph 是否进入主生成链路？</a:t>
             </a:r>
             <a:endParaRPr lang="en-US" sz="1200" dirty="0"/>
           </a:p>
@@ -3736,7 +3736,7 @@
         </p:nvSpPr>
         <p:spPr>
           <a:xfrm>
-            <a:off x="9784080" y="4059936"/>
+            <a:off x="9528048" y="4059936"/>
             <a:ext cx="256032" cy="219456"/>
           </a:xfrm>
           <a:prstGeom prst="rect">
@@ -3775,8 +3775,8 @@
         </p:nvSpPr>
         <p:spPr>
           <a:xfrm>
-            <a:off x="10195560" y="4059936"/>
-            <a:ext cx="950976" cy="438912"/>
+            <a:off x="9939528" y="4059936"/>
+            <a:ext cx="1234440" cy="438912"/>
           </a:xfrm>
           <a:prstGeom prst="rect">
             <a:avLst/>
@@ -3816,7 +3816,7 @@
         </p:nvSpPr>
         <p:spPr>
           <a:xfrm>
-            <a:off x="9784080" y="4745736"/>
+            <a:off x="9528048" y="4745736"/>
             <a:ext cx="256032" cy="219456"/>
           </a:xfrm>
           <a:prstGeom prst="rect">
@@ -3855,8 +3855,8 @@
         </p:nvSpPr>
         <p:spPr>
           <a:xfrm>
-            <a:off x="10195560" y="4745736"/>
-            <a:ext cx="950976" cy="438912"/>
+            <a:off x="9939528" y="4745736"/>
+            <a:ext cx="1234440" cy="438912"/>
           </a:xfrm>
           <a:prstGeom prst="rect">
             <a:avLst/>
@@ -4541,7 +4541,7 @@
         </p:nvSpPr>
         <p:spPr>
           <a:xfrm>
-            <a:off x="704088" y="5843016"/>
+            <a:off x="704088" y="5660136"/>
             <a:ext cx="8778240" cy="265176"/>
           </a:xfrm>
           <a:prstGeom prst="rect">
@@ -5005,23 +5005,23 @@
         <p:spPr>
           <a:xfrm>
             <a:off x="896112" y="2651760"/>
-            <a:ext cx="2148840" cy="1051560"/>
-          </a:xfrm>
-          <a:prstGeom prst="rect">
-            <a:avLst/>
-          </a:prstGeom>
-          <a:noFill/>
-          <a:ln/>
-        </p:spPr>
-        <p:txBody>
-          <a:bodyPr wrap="square" lIns="0" tIns="0" rIns="0" bIns="0" rtlCol="0" anchor="ctr"/>
-          <a:lstStyle/>
-          <a:p>
-            <a:pPr indent="0" marL="0">
-              <a:buNone/>
-            </a:pPr>
-            <a:r>
-              <a:rPr lang="en-US" sz="2900" b="1" dirty="0">
+            <a:ext cx="2148840" cy="896112"/>
+          </a:xfrm>
+          <a:prstGeom prst="rect">
+            <a:avLst/>
+          </a:prstGeom>
+          <a:noFill/>
+          <a:ln/>
+        </p:spPr>
+        <p:txBody>
+          <a:bodyPr wrap="square" lIns="0" tIns="0" rIns="0" bIns="0" rtlCol="0" anchor="ctr"/>
+          <a:lstStyle/>
+          <a:p>
+            <a:pPr indent="0" marL="0">
+              <a:buNone/>
+            </a:pPr>
+            <a:r>
+              <a:rPr lang="en-US" sz="2700" b="1" dirty="0">
                 <a:solidFill>
                   <a:srgbClr val="FFFFFF"/>
                 </a:solidFill>
@@ -5029,16 +5029,16 @@
                 <a:ea typeface="Georgia" pitchFamily="34" charset="-122"/>
                 <a:cs typeface="Georgia" pitchFamily="34" charset="-120"/>
               </a:rPr>
-              <a:t>能力可用</a:t>
-            </a:r>
-            <a:endParaRPr lang="en-US" sz="2900" dirty="0"/>
-          </a:p>
-          <a:p>
-            <a:pPr indent="0" marL="0">
-              <a:buNone/>
-            </a:pPr>
-            <a:r>
-              <a:rPr lang="en-US" sz="2900" b="1" dirty="0">
+              <a:t>能力完整</a:t>
+            </a:r>
+            <a:endParaRPr lang="en-US" sz="2700" dirty="0"/>
+          </a:p>
+          <a:p>
+            <a:pPr indent="0" marL="0">
+              <a:buNone/>
+            </a:pPr>
+            <a:r>
+              <a:rPr lang="en-US" sz="2700" b="1" dirty="0">
                 <a:solidFill>
                   <a:srgbClr val="FFFFFF"/>
                 </a:solidFill>
@@ -5046,9 +5046,9 @@
                 <a:ea typeface="Georgia" pitchFamily="34" charset="-122"/>
                 <a:cs typeface="Georgia" pitchFamily="34" charset="-120"/>
               </a:rPr>
-              <a:t>工程化待收口</a:t>
-            </a:r>
-            <a:endParaRPr lang="en-US" sz="2900" dirty="0"/>
+              <a:t>工程待收口</a:t>
+            </a:r>
+            <a:endParaRPr lang="en-US" sz="2700" dirty="0"/>
           </a:p>
         </p:txBody>
       </p:sp>
@@ -6902,7 +6902,7 @@
                 <a:ea typeface="Calibri" pitchFamily="34" charset="-122"/>
                 <a:cs typeface="Calibri" pitchFamily="34" charset="-120"/>
               </a:rPr>
-              <a:t>7 个 Maven 微服务模块</a:t>
+              <a:t>7 个微服务模块</a:t>
             </a:r>
             <a:endParaRPr lang="en-US" sz="1800" dirty="0"/>
           </a:p>
@@ -6943,7 +6943,7 @@
                 <a:ea typeface="Calibri" pitchFamily="34" charset="-122"/>
                 <a:cs typeface="Calibri" pitchFamily="34" charset="-120"/>
               </a:rPr>
-              <a:t>common · model · client · user · app · ai · screenshot</a:t>
+              <a:t>Maven：common · model · client · user · app · ai · screenshot</a:t>
             </a:r>
             <a:endParaRPr lang="en-US" sz="1300" dirty="0"/>
           </a:p>
@@ -11031,7 +11031,7 @@
                 <a:ea typeface="Calibri" pitchFamily="34" charset="-122"/>
                 <a:cs typeface="Calibri" pitchFamily="34" charset="-120"/>
               </a:rPr>
-              <a:t>昨日（07-18）无提交</a:t>
+              <a:t>昨日（07-18）无提交；</a:t>
             </a:r>
             <a:endParaRPr lang="en-US" sz="1400" dirty="0"/>
           </a:p>
@@ -11048,7 +11048,7 @@
                 <a:ea typeface="Calibri" pitchFamily="34" charset="-122"/>
                 <a:cs typeface="Calibri" pitchFamily="34" charset="-120"/>
               </a:rPr>
-              <a:t>今日汇报基于代码库静态快照</a:t>
+              <a:t>今日基于代码库静态快照</a:t>
             </a:r>
             <a:endParaRPr lang="en-US" sz="1400" dirty="0"/>
           </a:p>
@@ -12010,7 +12010,24 @@
                 <a:ea typeface="Calibri" pitchFamily="34" charset="-122"/>
                 <a:cs typeface="Calibri" pitchFamily="34" charset="-120"/>
               </a:rPr>
-              <a:t>微服务 Maven 模块</a:t>
+              <a:t>微服务模块</a:t>
+            </a:r>
+            <a:endParaRPr lang="en-US" sz="1400" dirty="0"/>
+          </a:p>
+          <a:p>
+            <a:pPr indent="0" marL="0">
+              <a:buNone/>
+            </a:pPr>
+            <a:r>
+              <a:rPr lang="en-US" sz="1400" b="1" dirty="0">
+                <a:solidFill>
+                  <a:srgbClr val="183B45"/>
+                </a:solidFill>
+                <a:latin typeface="Calibri" pitchFamily="34" charset="0"/>
+                <a:ea typeface="Calibri" pitchFamily="34" charset="-122"/>
+                <a:cs typeface="Calibri" pitchFamily="34" charset="-120"/>
+              </a:rPr>
+              <a:t>（Maven）</a:t>
             </a:r>
             <a:endParaRPr lang="en-US" sz="1400" dirty="0"/>
           </a:p>

</xml_diff>